<commit_message>
feat: export Vivado bitstream and hardware definition files for gaussian design
</commit_message>
<xml_diff>
--- a/sketch_generator.pptx
+++ b/sketch_generator.pptx
@@ -7,6 +7,12 @@
   <p:sldIdLst>
     <p:sldId id="256" r:id="rId2"/>
     <p:sldId id="257" r:id="rId3"/>
+    <p:sldId id="258" r:id="rId4"/>
+    <p:sldId id="259" r:id="rId5"/>
+    <p:sldId id="260" r:id="rId6"/>
+    <p:sldId id="263" r:id="rId7"/>
+    <p:sldId id="261" r:id="rId8"/>
+    <p:sldId id="262" r:id="rId9"/>
   </p:sldIdLst>
   <p:sldSz cx="12192000" cy="6858000"/>
   <p:notesSz cx="6858000" cy="9144000"/>
@@ -105,6 +111,11 @@
       </a:defRPr>
     </a:lvl9pPr>
   </p:defaultTextStyle>
+  <p:extLst>
+    <p:ext uri="{EFAFB233-063F-42B5-8137-9DF3F51BA10A}">
+      <p15:sldGuideLst xmlns:p15="http://schemas.microsoft.com/office/powerpoint/2012/main"/>
+    </p:ext>
+  </p:extLst>
 </p:presentation>
 </file>
 
@@ -3473,7 +3484,10 @@
           <a:bodyPr/>
           <a:lstStyle/>
           <a:p>
-            <a:endParaRPr lang="zh-TW" altLang="en-US" dirty="0"/>
+            <a:r>
+              <a:rPr lang="zh-TW" altLang="en-US" dirty="0"/>
+              <a:t>專案動機與系統目標</a:t>
+            </a:r>
           </a:p>
         </p:txBody>
       </p:sp>
@@ -3498,7 +3512,64 @@
           <a:bodyPr/>
           <a:lstStyle/>
           <a:p>
-            <a:endParaRPr lang="zh-TW" altLang="en-US"/>
+            <a:r>
+              <a:rPr lang="zh-TW" altLang="en-US" dirty="0"/>
+              <a:t>研究動機：現代影像濾鏡（如高斯模糊與色彩混疊）若由通用處理器 </a:t>
+            </a:r>
+            <a:r>
+              <a:rPr lang="en-US" altLang="zh-TW" dirty="0"/>
+              <a:t>(CPU) </a:t>
+            </a:r>
+            <a:r>
+              <a:rPr lang="zh-TW" altLang="en-US" dirty="0"/>
+              <a:t>以純軟體執行，常受限於記憶體頻寬與指令集開銷，難以滿足即時 </a:t>
+            </a:r>
+            <a:r>
+              <a:rPr lang="en-US" altLang="zh-TW" dirty="0"/>
+              <a:t>(Real-time) </a:t>
+            </a:r>
+            <a:r>
+              <a:rPr lang="zh-TW" altLang="en-US" dirty="0"/>
+              <a:t>處理之需求。</a:t>
+            </a:r>
+          </a:p>
+          <a:p>
+            <a:r>
+              <a:rPr lang="zh-TW" altLang="en-US" dirty="0"/>
+              <a:t>系統目標：基於 </a:t>
+            </a:r>
+            <a:r>
+              <a:rPr lang="en-US" altLang="zh-TW" dirty="0"/>
+              <a:t>Zynq-7000 SoC </a:t>
+            </a:r>
+            <a:r>
+              <a:rPr lang="zh-TW" altLang="en-US" dirty="0"/>
+              <a:t>架構，設計一具備高吞吐量 </a:t>
+            </a:r>
+            <a:r>
+              <a:rPr lang="en-US" altLang="zh-TW" dirty="0"/>
+              <a:t>($II=1$) </a:t>
+            </a:r>
+            <a:r>
+              <a:rPr lang="zh-TW" altLang="en-US" dirty="0"/>
+              <a:t>之專用硬體加速器 </a:t>
+            </a:r>
+            <a:r>
+              <a:rPr lang="en-US" altLang="zh-TW" dirty="0"/>
+              <a:t>(Hardware Accelerator)</a:t>
+            </a:r>
+            <a:r>
+              <a:rPr lang="zh-TW" altLang="en-US" dirty="0"/>
+              <a:t>，以減輕 </a:t>
+            </a:r>
+            <a:r>
+              <a:rPr lang="en-US" altLang="zh-TW" dirty="0"/>
+              <a:t>CPU </a:t>
+            </a:r>
+            <a:r>
+              <a:rPr lang="zh-TW" altLang="en-US" dirty="0"/>
+              <a:t>負載並達成即時影像轉換。</a:t>
+            </a:r>
           </a:p>
         </p:txBody>
       </p:sp>
@@ -3506,6 +3577,1048 @@
     <p:extLst>
       <p:ext uri="{BB962C8B-B14F-4D97-AF65-F5344CB8AC3E}">
         <p14:creationId xmlns:p14="http://schemas.microsoft.com/office/powerpoint/2010/main" val="3582522608"/>
+      </p:ext>
+    </p:extLst>
+  </p:cSld>
+  <p:clrMapOvr>
+    <a:masterClrMapping/>
+  </p:clrMapOvr>
+</p:sld>
+</file>
+
+<file path=ppt/slides/slide3.xml><?xml version="1.0" encoding="utf-8"?>
+<p:sld xmlns:a="http://schemas.openxmlformats.org/drawingml/2006/main" xmlns:r="http://schemas.openxmlformats.org/officeDocument/2006/relationships" xmlns:p="http://schemas.openxmlformats.org/presentationml/2006/main">
+  <p:cSld>
+    <p:spTree>
+      <p:nvGrpSpPr>
+        <p:cNvPr id="1" name=""/>
+        <p:cNvGrpSpPr/>
+        <p:nvPr/>
+      </p:nvGrpSpPr>
+      <p:grpSpPr>
+        <a:xfrm>
+          <a:off x="0" y="0"/>
+          <a:ext cx="0" cy="0"/>
+          <a:chOff x="0" y="0"/>
+          <a:chExt cx="0" cy="0"/>
+        </a:xfrm>
+      </p:grpSpPr>
+      <p:sp>
+        <p:nvSpPr>
+          <p:cNvPr id="2" name="標題 1">
+            <a:extLst>
+              <a:ext uri="{FF2B5EF4-FFF2-40B4-BE49-F238E27FC236}">
+                <a16:creationId xmlns:a16="http://schemas.microsoft.com/office/drawing/2014/main" id="{01146A7D-CE3B-4041-1946-6CE21D9BF38C}"/>
+              </a:ext>
+            </a:extLst>
+          </p:cNvPr>
+          <p:cNvSpPr>
+            <a:spLocks noGrp="1"/>
+          </p:cNvSpPr>
+          <p:nvPr>
+            <p:ph type="title"/>
+          </p:nvPr>
+        </p:nvSpPr>
+        <p:spPr/>
+        <p:txBody>
+          <a:bodyPr/>
+          <a:lstStyle/>
+          <a:p>
+            <a:r>
+              <a:rPr lang="zh-TW" altLang="en-US" dirty="0"/>
+              <a:t>演算法分析與設計</a:t>
+            </a:r>
+          </a:p>
+        </p:txBody>
+      </p:sp>
+      <p:sp>
+        <p:nvSpPr>
+          <p:cNvPr id="3" name="內容版面配置區 2">
+            <a:extLst>
+              <a:ext uri="{FF2B5EF4-FFF2-40B4-BE49-F238E27FC236}">
+                <a16:creationId xmlns:a16="http://schemas.microsoft.com/office/drawing/2014/main" id="{E26AE8E0-BD5C-0680-F696-7861D4A58739}"/>
+              </a:ext>
+            </a:extLst>
+          </p:cNvPr>
+          <p:cNvSpPr>
+            <a:spLocks noGrp="1"/>
+          </p:cNvSpPr>
+          <p:nvPr>
+            <p:ph idx="1"/>
+          </p:nvPr>
+        </p:nvSpPr>
+        <p:spPr/>
+        <p:txBody>
+          <a:bodyPr/>
+          <a:lstStyle/>
+          <a:p>
+            <a:r>
+              <a:rPr lang="zh-TW" altLang="en-US" dirty="0"/>
+              <a:t>演算法演進與比較：</a:t>
+            </a:r>
+          </a:p>
+          <a:p>
+            <a:r>
+              <a:rPr lang="zh-TW" altLang="en-US" dirty="0"/>
+              <a:t>初期實作 </a:t>
+            </a:r>
+            <a:r>
+              <a:rPr lang="en-US" altLang="zh-TW" dirty="0"/>
+              <a:t>(Sobel Edge Detection)</a:t>
+            </a:r>
+            <a:r>
+              <a:rPr lang="zh-TW" altLang="en-US" dirty="0"/>
+              <a:t>：採用 </a:t>
+            </a:r>
+            <a:r>
+              <a:rPr lang="en-US" altLang="zh-TW" dirty="0"/>
+              <a:t>$3 \times 3$ </a:t>
+            </a:r>
+            <a:r>
+              <a:rPr lang="zh-TW" altLang="en-US" dirty="0"/>
+              <a:t>梯度運算，運算成本低但影像輪廓生硬，缺乏光影細節。</a:t>
+            </a:r>
+          </a:p>
+          <a:p>
+            <a:r>
+              <a:rPr lang="zh-TW" altLang="en-US" dirty="0"/>
+              <a:t>改良實作 </a:t>
+            </a:r>
+            <a:r>
+              <a:rPr lang="en-US" altLang="zh-TW" dirty="0"/>
+              <a:t>(Gaussian Blur &amp; Color Dodge)</a:t>
+            </a:r>
+            <a:r>
+              <a:rPr lang="zh-TW" altLang="en-US" dirty="0"/>
+              <a:t>：為達到平滑漸層之真實素描效果，升級為 </a:t>
+            </a:r>
+            <a:r>
+              <a:rPr lang="en-US" altLang="zh-TW" dirty="0"/>
+              <a:t>$5 \times 5$ </a:t>
+            </a:r>
+            <a:r>
+              <a:rPr lang="zh-TW" altLang="en-US" dirty="0"/>
+              <a:t>高斯模糊卷積，並透過色彩加亮演算法進行像素混疊 </a:t>
+            </a:r>
+            <a:r>
+              <a:rPr lang="en-US" altLang="zh-TW" dirty="0"/>
+              <a:t>(Pixel Blending)</a:t>
+            </a:r>
+            <a:r>
+              <a:rPr lang="zh-TW" altLang="en-US" dirty="0"/>
+              <a:t>。</a:t>
+            </a:r>
+          </a:p>
+        </p:txBody>
+      </p:sp>
+    </p:spTree>
+    <p:extLst>
+      <p:ext uri="{BB962C8B-B14F-4D97-AF65-F5344CB8AC3E}">
+        <p14:creationId xmlns:p14="http://schemas.microsoft.com/office/powerpoint/2010/main" val="3024374226"/>
+      </p:ext>
+    </p:extLst>
+  </p:cSld>
+  <p:clrMapOvr>
+    <a:masterClrMapping/>
+  </p:clrMapOvr>
+</p:sld>
+</file>
+
+<file path=ppt/slides/slide4.xml><?xml version="1.0" encoding="utf-8"?>
+<p:sld xmlns:a="http://schemas.openxmlformats.org/drawingml/2006/main" xmlns:r="http://schemas.openxmlformats.org/officeDocument/2006/relationships" xmlns:p="http://schemas.openxmlformats.org/presentationml/2006/main">
+  <p:cSld>
+    <p:spTree>
+      <p:nvGrpSpPr>
+        <p:cNvPr id="1" name=""/>
+        <p:cNvGrpSpPr/>
+        <p:nvPr/>
+      </p:nvGrpSpPr>
+      <p:grpSpPr>
+        <a:xfrm>
+          <a:off x="0" y="0"/>
+          <a:ext cx="0" cy="0"/>
+          <a:chOff x="0" y="0"/>
+          <a:chExt cx="0" cy="0"/>
+        </a:xfrm>
+      </p:grpSpPr>
+      <p:sp>
+        <p:nvSpPr>
+          <p:cNvPr id="2" name="標題 1">
+            <a:extLst>
+              <a:ext uri="{FF2B5EF4-FFF2-40B4-BE49-F238E27FC236}">
+                <a16:creationId xmlns:a16="http://schemas.microsoft.com/office/drawing/2014/main" id="{59DE0AD9-3AD3-A536-A2FD-976E1122209F}"/>
+              </a:ext>
+            </a:extLst>
+          </p:cNvPr>
+          <p:cNvSpPr>
+            <a:spLocks noGrp="1"/>
+          </p:cNvSpPr>
+          <p:nvPr>
+            <p:ph type="title"/>
+          </p:nvPr>
+        </p:nvSpPr>
+        <p:spPr/>
+        <p:txBody>
+          <a:bodyPr/>
+          <a:lstStyle/>
+          <a:p>
+            <a:r>
+              <a:rPr lang="zh-TW" altLang="en-US" dirty="0"/>
+              <a:t>硬體微架構設計與最佳化</a:t>
+            </a:r>
+          </a:p>
+        </p:txBody>
+      </p:sp>
+      <p:sp>
+        <p:nvSpPr>
+          <p:cNvPr id="3" name="內容版面配置區 2">
+            <a:extLst>
+              <a:ext uri="{FF2B5EF4-FFF2-40B4-BE49-F238E27FC236}">
+                <a16:creationId xmlns:a16="http://schemas.microsoft.com/office/drawing/2014/main" id="{3DAA8702-3075-8927-BDDD-637BB90BDDE0}"/>
+              </a:ext>
+            </a:extLst>
+          </p:cNvPr>
+          <p:cNvSpPr>
+            <a:spLocks noGrp="1"/>
+          </p:cNvSpPr>
+          <p:nvPr>
+            <p:ph idx="1"/>
+          </p:nvPr>
+        </p:nvSpPr>
+        <p:spPr/>
+        <p:txBody>
+          <a:bodyPr/>
+          <a:lstStyle/>
+          <a:p>
+            <a:r>
+              <a:rPr lang="zh-TW" altLang="en-US" dirty="0"/>
+              <a:t>記憶體階層優化 </a:t>
+            </a:r>
+            <a:r>
+              <a:rPr lang="en-US" altLang="zh-TW" dirty="0"/>
+              <a:t>(Memory Hierarchy Optimization)</a:t>
+            </a:r>
+            <a:r>
+              <a:rPr lang="zh-TW" altLang="en-US" dirty="0"/>
+              <a:t>：針對影像卷積之空間局部性 </a:t>
+            </a:r>
+            <a:r>
+              <a:rPr lang="en-US" altLang="zh-TW" dirty="0"/>
+              <a:t>(Spatial Locality)</a:t>
+            </a:r>
+            <a:r>
+              <a:rPr lang="zh-TW" altLang="en-US" dirty="0"/>
+              <a:t>，客製化 </a:t>
+            </a:r>
+            <a:r>
+              <a:rPr lang="en-US" altLang="zh-TW" dirty="0"/>
+              <a:t>$5 \times 5$ </a:t>
+            </a:r>
+            <a:r>
+              <a:rPr lang="zh-TW" altLang="en-US" dirty="0"/>
+              <a:t>之 </a:t>
+            </a:r>
+            <a:r>
+              <a:rPr lang="en-US" altLang="zh-TW" dirty="0"/>
+              <a:t>Line Buffer </a:t>
+            </a:r>
+            <a:r>
+              <a:rPr lang="zh-TW" altLang="en-US" dirty="0"/>
+              <a:t>與 </a:t>
+            </a:r>
+            <a:r>
+              <a:rPr lang="en-US" altLang="zh-TW" dirty="0"/>
+              <a:t>Window Buffer </a:t>
+            </a:r>
+            <a:r>
+              <a:rPr lang="zh-TW" altLang="en-US" dirty="0"/>
+              <a:t>移位暫存器結構，將外部記憶體存取次數降至最低。</a:t>
+            </a:r>
+          </a:p>
+          <a:p>
+            <a:r>
+              <a:rPr lang="zh-TW" altLang="en-US" dirty="0"/>
+              <a:t>零時延除法與防溢位設計：於 </a:t>
+            </a:r>
+            <a:r>
+              <a:rPr lang="en-US" altLang="zh-TW" dirty="0"/>
+              <a:t>Color Dodge </a:t>
+            </a:r>
+            <a:r>
+              <a:rPr lang="zh-TW" altLang="en-US" dirty="0"/>
+              <a:t>運算中，藉由將高斯權重總和設計為 </a:t>
+            </a:r>
+            <a:r>
+              <a:rPr lang="en-US" altLang="zh-TW" dirty="0"/>
+              <a:t>256</a:t>
+            </a:r>
+            <a:r>
+              <a:rPr lang="zh-TW" altLang="en-US" dirty="0"/>
+              <a:t>，以位元右移 </a:t>
+            </a:r>
+            <a:r>
+              <a:rPr lang="en-US" altLang="zh-TW" dirty="0"/>
+              <a:t>(&gt;&gt; 8) </a:t>
+            </a:r>
+            <a:r>
+              <a:rPr lang="zh-TW" altLang="en-US" dirty="0"/>
+              <a:t>取代硬體除法器；並於分母加入常數補償 </a:t>
+            </a:r>
+            <a:r>
+              <a:rPr lang="en-US" altLang="zh-TW" dirty="0"/>
+              <a:t>(B+1) </a:t>
+            </a:r>
+            <a:r>
+              <a:rPr lang="zh-TW" altLang="en-US" dirty="0"/>
+              <a:t>以確保系統穩定性 </a:t>
+            </a:r>
+            <a:r>
+              <a:rPr lang="en-US" altLang="zh-TW" dirty="0"/>
+              <a:t>(</a:t>
+            </a:r>
+            <a:r>
+              <a:rPr lang="zh-TW" altLang="en-US" dirty="0"/>
+              <a:t>避免 </a:t>
+            </a:r>
+            <a:r>
+              <a:rPr lang="en-US" altLang="zh-TW" dirty="0"/>
+              <a:t>Divide-by-Zero Exception)</a:t>
+            </a:r>
+            <a:r>
+              <a:rPr lang="zh-TW" altLang="en-US" dirty="0"/>
+              <a:t>。</a:t>
+            </a:r>
+          </a:p>
+          <a:p>
+            <a:r>
+              <a:rPr lang="zh-TW" altLang="en-US" dirty="0"/>
+              <a:t>管線化處理 </a:t>
+            </a:r>
+            <a:r>
+              <a:rPr lang="en-US" altLang="zh-TW" dirty="0"/>
+              <a:t>(Pipelining)</a:t>
+            </a:r>
+            <a:r>
+              <a:rPr lang="zh-TW" altLang="en-US" dirty="0"/>
+              <a:t>：展示 </a:t>
+            </a:r>
+            <a:r>
+              <a:rPr lang="en-US" altLang="zh-TW" dirty="0"/>
+              <a:t>Vitis HLS </a:t>
+            </a:r>
+            <a:r>
+              <a:rPr lang="zh-TW" altLang="en-US" dirty="0"/>
+              <a:t>之合成報告，證明系統成功達成 </a:t>
+            </a:r>
+            <a:r>
+              <a:rPr lang="en-US" altLang="zh-TW" dirty="0"/>
+              <a:t>Initiation Interval (II) = 1 </a:t>
+            </a:r>
+            <a:r>
+              <a:rPr lang="zh-TW" altLang="en-US" dirty="0"/>
+              <a:t>之理想吞吐量。</a:t>
+            </a:r>
+          </a:p>
+        </p:txBody>
+      </p:sp>
+    </p:spTree>
+    <p:extLst>
+      <p:ext uri="{BB962C8B-B14F-4D97-AF65-F5344CB8AC3E}">
+        <p14:creationId xmlns:p14="http://schemas.microsoft.com/office/powerpoint/2010/main" val="3745515467"/>
+      </p:ext>
+    </p:extLst>
+  </p:cSld>
+  <p:clrMapOvr>
+    <a:masterClrMapping/>
+  </p:clrMapOvr>
+</p:sld>
+</file>
+
+<file path=ppt/slides/slide5.xml><?xml version="1.0" encoding="utf-8"?>
+<p:sld xmlns:a="http://schemas.openxmlformats.org/drawingml/2006/main" xmlns:r="http://schemas.openxmlformats.org/officeDocument/2006/relationships" xmlns:p="http://schemas.openxmlformats.org/presentationml/2006/main">
+  <p:cSld>
+    <p:spTree>
+      <p:nvGrpSpPr>
+        <p:cNvPr id="1" name=""/>
+        <p:cNvGrpSpPr/>
+        <p:nvPr/>
+      </p:nvGrpSpPr>
+      <p:grpSpPr>
+        <a:xfrm>
+          <a:off x="0" y="0"/>
+          <a:ext cx="0" cy="0"/>
+          <a:chOff x="0" y="0"/>
+          <a:chExt cx="0" cy="0"/>
+        </a:xfrm>
+      </p:grpSpPr>
+      <p:sp>
+        <p:nvSpPr>
+          <p:cNvPr id="2" name="標題 1">
+            <a:extLst>
+              <a:ext uri="{FF2B5EF4-FFF2-40B4-BE49-F238E27FC236}">
+                <a16:creationId xmlns:a16="http://schemas.microsoft.com/office/drawing/2014/main" id="{1ED68ACE-4BFA-5F59-BBBA-C6AC8A47211E}"/>
+              </a:ext>
+            </a:extLst>
+          </p:cNvPr>
+          <p:cNvSpPr>
+            <a:spLocks noGrp="1"/>
+          </p:cNvSpPr>
+          <p:nvPr>
+            <p:ph type="title"/>
+          </p:nvPr>
+        </p:nvSpPr>
+        <p:spPr/>
+        <p:txBody>
+          <a:bodyPr/>
+          <a:lstStyle/>
+          <a:p>
+            <a:r>
+              <a:rPr lang="zh-TW" altLang="en-US" dirty="0"/>
+              <a:t>軟硬體協同設計與系統整合</a:t>
+            </a:r>
+          </a:p>
+        </p:txBody>
+      </p:sp>
+      <p:sp>
+        <p:nvSpPr>
+          <p:cNvPr id="3" name="內容版面配置區 2">
+            <a:extLst>
+              <a:ext uri="{FF2B5EF4-FFF2-40B4-BE49-F238E27FC236}">
+                <a16:creationId xmlns:a16="http://schemas.microsoft.com/office/drawing/2014/main" id="{24C8565D-9C0C-BF63-7A79-F6B95400B796}"/>
+              </a:ext>
+            </a:extLst>
+          </p:cNvPr>
+          <p:cNvSpPr>
+            <a:spLocks noGrp="1"/>
+          </p:cNvSpPr>
+          <p:nvPr>
+            <p:ph idx="1"/>
+          </p:nvPr>
+        </p:nvSpPr>
+        <p:spPr/>
+        <p:txBody>
+          <a:bodyPr/>
+          <a:lstStyle/>
+          <a:p>
+            <a:r>
+              <a:rPr lang="en-US" altLang="zh-TW" dirty="0"/>
+              <a:t>AXI </a:t>
+            </a:r>
+            <a:r>
+              <a:rPr lang="zh-TW" altLang="en-US" dirty="0"/>
+              <a:t>匯流排架構設計：</a:t>
+            </a:r>
+          </a:p>
+          <a:p>
+            <a:r>
+              <a:rPr lang="zh-TW" altLang="en-US" dirty="0"/>
+              <a:t>控制層面：由 </a:t>
+            </a:r>
+            <a:r>
+              <a:rPr lang="en-US" altLang="zh-TW" dirty="0"/>
+              <a:t>PS </a:t>
+            </a:r>
+            <a:r>
+              <a:rPr lang="zh-TW" altLang="en-US" dirty="0"/>
+              <a:t>端透過 </a:t>
+            </a:r>
+            <a:r>
+              <a:rPr lang="en-US" altLang="zh-TW" dirty="0"/>
+              <a:t>AXI-Lite </a:t>
+            </a:r>
+            <a:r>
+              <a:rPr lang="zh-TW" altLang="en-US" dirty="0"/>
+              <a:t>介面配置影像解析度與控制訊號。</a:t>
+            </a:r>
+          </a:p>
+          <a:p>
+            <a:r>
+              <a:rPr lang="zh-TW" altLang="en-US" dirty="0"/>
+              <a:t>資料層面：由 </a:t>
+            </a:r>
+            <a:r>
+              <a:rPr lang="en-US" altLang="zh-TW" dirty="0"/>
+              <a:t>IP </a:t>
+            </a:r>
+            <a:r>
+              <a:rPr lang="zh-TW" altLang="en-US" dirty="0"/>
+              <a:t>內建之 </a:t>
+            </a:r>
+            <a:r>
+              <a:rPr lang="en-US" altLang="zh-TW" dirty="0"/>
+              <a:t>AXI Master </a:t>
+            </a:r>
+            <a:r>
+              <a:rPr lang="zh-TW" altLang="en-US" dirty="0"/>
+              <a:t>介面主動存取 </a:t>
+            </a:r>
+            <a:r>
+              <a:rPr lang="en-US" altLang="zh-TW" dirty="0"/>
+              <a:t>DDR </a:t>
+            </a:r>
+            <a:r>
+              <a:rPr lang="zh-TW" altLang="en-US" dirty="0"/>
+              <a:t>記憶體 </a:t>
+            </a:r>
+            <a:r>
+              <a:rPr lang="en-US" altLang="zh-TW" dirty="0"/>
+              <a:t>(DMA </a:t>
+            </a:r>
+            <a:r>
+              <a:rPr lang="zh-TW" altLang="en-US" dirty="0"/>
+              <a:t>傳輸</a:t>
+            </a:r>
+            <a:r>
+              <a:rPr lang="en-US" altLang="zh-TW" dirty="0"/>
+              <a:t>)</a:t>
+            </a:r>
+            <a:r>
+              <a:rPr lang="zh-TW" altLang="en-US" dirty="0"/>
+              <a:t>。</a:t>
+            </a:r>
+          </a:p>
+          <a:p>
+            <a:r>
+              <a:rPr lang="zh-TW" altLang="en-US" dirty="0"/>
+              <a:t>系統實作挑戰與對策：說明在 </a:t>
+            </a:r>
+            <a:r>
+              <a:rPr lang="en-US" altLang="zh-TW" dirty="0" err="1"/>
+              <a:t>Vivado</a:t>
+            </a:r>
+            <a:r>
+              <a:rPr lang="en-US" altLang="zh-TW" dirty="0"/>
+              <a:t> Block Design </a:t>
+            </a:r>
+            <a:r>
+              <a:rPr lang="zh-TW" altLang="en-US" dirty="0"/>
+              <a:t>中，為避免 </a:t>
+            </a:r>
+            <a:r>
+              <a:rPr lang="en-US" altLang="zh-TW" dirty="0"/>
+              <a:t>AXI Crossbar </a:t>
+            </a:r>
+            <a:r>
+              <a:rPr lang="zh-TW" altLang="en-US" dirty="0"/>
+              <a:t>之位址衝突 </a:t>
+            </a:r>
+            <a:r>
+              <a:rPr lang="en-US" altLang="zh-TW" dirty="0"/>
+              <a:t>(Address Overlap)</a:t>
+            </a:r>
+            <a:r>
+              <a:rPr lang="zh-TW" altLang="en-US" dirty="0"/>
+              <a:t>，採用雙通道獨立傳輸（</a:t>
+            </a:r>
+            <a:r>
+              <a:rPr lang="en-US" altLang="zh-TW" dirty="0"/>
+              <a:t>HP0 </a:t>
+            </a:r>
+            <a:r>
+              <a:rPr lang="zh-TW" altLang="en-US" dirty="0"/>
+              <a:t>負責讀取，</a:t>
+            </a:r>
+            <a:r>
+              <a:rPr lang="en-US" altLang="zh-TW" dirty="0"/>
+              <a:t>HP1 </a:t>
+            </a:r>
+            <a:r>
+              <a:rPr lang="zh-TW" altLang="en-US" dirty="0"/>
+              <a:t>負責寫入）以最大化記憶體頻寬。</a:t>
+            </a:r>
+          </a:p>
+        </p:txBody>
+      </p:sp>
+    </p:spTree>
+    <p:extLst>
+      <p:ext uri="{BB962C8B-B14F-4D97-AF65-F5344CB8AC3E}">
+        <p14:creationId xmlns:p14="http://schemas.microsoft.com/office/powerpoint/2010/main" val="3618792571"/>
+      </p:ext>
+    </p:extLst>
+  </p:cSld>
+  <p:clrMapOvr>
+    <a:masterClrMapping/>
+  </p:clrMapOvr>
+</p:sld>
+</file>
+
+<file path=ppt/slides/slide6.xml><?xml version="1.0" encoding="utf-8"?>
+<p:sld xmlns:a="http://schemas.openxmlformats.org/drawingml/2006/main" xmlns:r="http://schemas.openxmlformats.org/officeDocument/2006/relationships" xmlns:p="http://schemas.openxmlformats.org/presentationml/2006/main">
+  <p:cSld>
+    <p:spTree>
+      <p:nvGrpSpPr>
+        <p:cNvPr id="1" name=""/>
+        <p:cNvGrpSpPr/>
+        <p:nvPr/>
+      </p:nvGrpSpPr>
+      <p:grpSpPr>
+        <a:xfrm>
+          <a:off x="0" y="0"/>
+          <a:ext cx="0" cy="0"/>
+          <a:chOff x="0" y="0"/>
+          <a:chExt cx="0" cy="0"/>
+        </a:xfrm>
+      </p:grpSpPr>
+      <p:sp>
+        <p:nvSpPr>
+          <p:cNvPr id="2" name="標題 1">
+            <a:extLst>
+              <a:ext uri="{FF2B5EF4-FFF2-40B4-BE49-F238E27FC236}">
+                <a16:creationId xmlns:a16="http://schemas.microsoft.com/office/drawing/2014/main" id="{81279ABE-9876-FEDB-7998-8329D758382F}"/>
+              </a:ext>
+            </a:extLst>
+          </p:cNvPr>
+          <p:cNvSpPr>
+            <a:spLocks noGrp="1"/>
+          </p:cNvSpPr>
+          <p:nvPr>
+            <p:ph type="title"/>
+          </p:nvPr>
+        </p:nvSpPr>
+        <p:spPr/>
+        <p:txBody>
+          <a:bodyPr/>
+          <a:lstStyle/>
+          <a:p>
+            <a:r>
+              <a:rPr lang="zh-TW" altLang="en-US" dirty="0"/>
+              <a:t>軟硬體協同設計與系統整合</a:t>
+            </a:r>
+          </a:p>
+        </p:txBody>
+      </p:sp>
+      <p:pic>
+        <p:nvPicPr>
+          <p:cNvPr id="5" name="內容版面配置區 4">
+            <a:extLst>
+              <a:ext uri="{FF2B5EF4-FFF2-40B4-BE49-F238E27FC236}">
+                <a16:creationId xmlns:a16="http://schemas.microsoft.com/office/drawing/2014/main" id="{56A60900-F3F1-3CFB-A5A4-E18209D6723C}"/>
+              </a:ext>
+            </a:extLst>
+          </p:cNvPr>
+          <p:cNvPicPr>
+            <a:picLocks noGrp="1" noChangeAspect="1"/>
+          </p:cNvPicPr>
+          <p:nvPr>
+            <p:ph idx="1"/>
+          </p:nvPr>
+        </p:nvPicPr>
+        <p:blipFill>
+          <a:blip r:embed="rId2">
+            <a:extLst>
+              <a:ext uri="{28A0092B-C50C-407E-A947-70E740481C1C}">
+                <a14:useLocalDpi xmlns:a14="http://schemas.microsoft.com/office/drawing/2010/main" val="0"/>
+              </a:ext>
+            </a:extLst>
+          </a:blip>
+          <a:srcRect l="1027" t="2181"/>
+          <a:stretch/>
+        </p:blipFill>
+        <p:spPr>
+          <a:xfrm>
+            <a:off x="892175" y="1365250"/>
+            <a:ext cx="10407650" cy="5270061"/>
+          </a:xfrm>
+        </p:spPr>
+      </p:pic>
+    </p:spTree>
+    <p:extLst>
+      <p:ext uri="{BB962C8B-B14F-4D97-AF65-F5344CB8AC3E}">
+        <p14:creationId xmlns:p14="http://schemas.microsoft.com/office/powerpoint/2010/main" val="2366058901"/>
+      </p:ext>
+    </p:extLst>
+  </p:cSld>
+  <p:clrMapOvr>
+    <a:masterClrMapping/>
+  </p:clrMapOvr>
+</p:sld>
+</file>
+
+<file path=ppt/slides/slide7.xml><?xml version="1.0" encoding="utf-8"?>
+<p:sld xmlns:a="http://schemas.openxmlformats.org/drawingml/2006/main" xmlns:r="http://schemas.openxmlformats.org/officeDocument/2006/relationships" xmlns:p="http://schemas.openxmlformats.org/presentationml/2006/main">
+  <p:cSld>
+    <p:spTree>
+      <p:nvGrpSpPr>
+        <p:cNvPr id="1" name=""/>
+        <p:cNvGrpSpPr/>
+        <p:nvPr/>
+      </p:nvGrpSpPr>
+      <p:grpSpPr>
+        <a:xfrm>
+          <a:off x="0" y="0"/>
+          <a:ext cx="0" cy="0"/>
+          <a:chOff x="0" y="0"/>
+          <a:chExt cx="0" cy="0"/>
+        </a:xfrm>
+      </p:grpSpPr>
+      <p:sp>
+        <p:nvSpPr>
+          <p:cNvPr id="2" name="標題 1">
+            <a:extLst>
+              <a:ext uri="{FF2B5EF4-FFF2-40B4-BE49-F238E27FC236}">
+                <a16:creationId xmlns:a16="http://schemas.microsoft.com/office/drawing/2014/main" id="{C4A76E00-5B7E-A811-94AD-EE6981CFA66D}"/>
+              </a:ext>
+            </a:extLst>
+          </p:cNvPr>
+          <p:cNvSpPr>
+            <a:spLocks noGrp="1"/>
+          </p:cNvSpPr>
+          <p:nvPr>
+            <p:ph type="title"/>
+          </p:nvPr>
+        </p:nvSpPr>
+        <p:spPr/>
+        <p:txBody>
+          <a:bodyPr/>
+          <a:lstStyle/>
+          <a:p>
+            <a:r>
+              <a:rPr lang="zh-TW" altLang="en-US" dirty="0"/>
+              <a:t>系統效能評估與瓶頸分析</a:t>
+            </a:r>
+          </a:p>
+        </p:txBody>
+      </p:sp>
+      <p:sp>
+        <p:nvSpPr>
+          <p:cNvPr id="3" name="內容版面配置區 2">
+            <a:extLst>
+              <a:ext uri="{FF2B5EF4-FFF2-40B4-BE49-F238E27FC236}">
+                <a16:creationId xmlns:a16="http://schemas.microsoft.com/office/drawing/2014/main" id="{314329DE-5644-0850-BAC9-6385CA13648E}"/>
+              </a:ext>
+            </a:extLst>
+          </p:cNvPr>
+          <p:cNvSpPr>
+            <a:spLocks noGrp="1"/>
+          </p:cNvSpPr>
+          <p:nvPr>
+            <p:ph idx="1"/>
+          </p:nvPr>
+        </p:nvSpPr>
+        <p:spPr/>
+        <p:txBody>
+          <a:bodyPr/>
+          <a:lstStyle/>
+          <a:p>
+            <a:r>
+              <a:rPr lang="zh-TW" altLang="en-US" dirty="0"/>
+              <a:t>硬體加速效能表現：展示 </a:t>
+            </a:r>
+            <a:r>
+              <a:rPr lang="en-US" altLang="zh-TW" dirty="0"/>
+              <a:t>FPGA </a:t>
+            </a:r>
+            <a:r>
+              <a:rPr lang="zh-TW" altLang="en-US" dirty="0"/>
+              <a:t>在 </a:t>
+            </a:r>
+            <a:r>
+              <a:rPr lang="en-US" altLang="zh-TW" dirty="0"/>
+              <a:t>720p </a:t>
+            </a:r>
+            <a:r>
+              <a:rPr lang="zh-TW" altLang="en-US" dirty="0"/>
+              <a:t>影像下之運算延遲為 </a:t>
+            </a:r>
+            <a:r>
+              <a:rPr lang="en-US" altLang="zh-TW" dirty="0"/>
+              <a:t>10.19 </a:t>
+            </a:r>
+            <a:r>
+              <a:rPr lang="en-US" altLang="zh-TW" dirty="0" err="1"/>
+              <a:t>ms</a:t>
+            </a:r>
+            <a:r>
+              <a:rPr lang="en-US" altLang="zh-TW" dirty="0"/>
+              <a:t> (</a:t>
+            </a:r>
+            <a:r>
+              <a:rPr lang="zh-TW" altLang="en-US" dirty="0"/>
+              <a:t>約等同於 </a:t>
+            </a:r>
+            <a:r>
+              <a:rPr lang="en-US" altLang="zh-TW" dirty="0"/>
+              <a:t>98 FPS)</a:t>
+            </a:r>
+            <a:r>
+              <a:rPr lang="zh-TW" altLang="en-US" dirty="0"/>
+              <a:t>，證明硬體核心已具備極高之即時處理能力。</a:t>
+            </a:r>
+          </a:p>
+          <a:p>
+            <a:r>
+              <a:rPr lang="zh-TW" altLang="en-US" dirty="0"/>
+              <a:t>軟硬體效能比較：對比純 </a:t>
+            </a:r>
+            <a:r>
+              <a:rPr lang="en-US" altLang="zh-TW" dirty="0"/>
+              <a:t>Python </a:t>
+            </a:r>
+            <a:r>
+              <a:rPr lang="zh-TW" altLang="en-US" dirty="0"/>
+              <a:t>執行該演算法之執行時間。</a:t>
+            </a:r>
+          </a:p>
+          <a:p>
+            <a:r>
+              <a:rPr lang="zh-TW" altLang="en-US" dirty="0"/>
+              <a:t>系統瓶頸分析 </a:t>
+            </a:r>
+            <a:r>
+              <a:rPr lang="en-US" altLang="zh-TW" dirty="0"/>
+              <a:t>(System Bottleneck)</a:t>
+            </a:r>
+            <a:r>
+              <a:rPr lang="zh-TW" altLang="en-US" dirty="0"/>
+              <a:t>：以客觀角度分析「動態影片處理速率較低」之主因。解釋瓶頸並非在於 </a:t>
+            </a:r>
+            <a:r>
+              <a:rPr lang="en-US" altLang="zh-TW" dirty="0"/>
+              <a:t>FPGA </a:t>
+            </a:r>
+            <a:r>
+              <a:rPr lang="zh-TW" altLang="en-US" dirty="0"/>
+              <a:t>運算，而是源於 </a:t>
+            </a:r>
+            <a:r>
+              <a:rPr lang="en-US" altLang="zh-TW" dirty="0"/>
+              <a:t>PS </a:t>
+            </a:r>
+            <a:r>
+              <a:rPr lang="zh-TW" altLang="en-US" dirty="0"/>
+              <a:t>端 </a:t>
+            </a:r>
+            <a:r>
+              <a:rPr lang="en-US" altLang="zh-TW" dirty="0"/>
+              <a:t>(ARM CPU) </a:t>
+            </a:r>
+            <a:r>
+              <a:rPr lang="zh-TW" altLang="en-US" dirty="0"/>
+              <a:t>執行 </a:t>
+            </a:r>
+            <a:r>
+              <a:rPr lang="en-US" altLang="zh-TW" dirty="0"/>
+              <a:t>Python OpenCV </a:t>
+            </a:r>
+            <a:r>
+              <a:rPr lang="zh-TW" altLang="en-US" dirty="0"/>
+              <a:t>影片解碼、檔案 </a:t>
+            </a:r>
+            <a:r>
+              <a:rPr lang="en-US" altLang="zh-TW" dirty="0"/>
+              <a:t>I/O </a:t>
+            </a:r>
+            <a:r>
+              <a:rPr lang="zh-TW" altLang="en-US" dirty="0"/>
+              <a:t>以及作業系統記憶體複製 </a:t>
+            </a:r>
+            <a:r>
+              <a:rPr lang="en-US" altLang="zh-TW" dirty="0"/>
+              <a:t>(Memory Copy) </a:t>
+            </a:r>
+            <a:r>
+              <a:rPr lang="zh-TW" altLang="en-US" dirty="0"/>
+              <a:t>之軟體開銷 </a:t>
+            </a:r>
+            <a:r>
+              <a:rPr lang="en-US" altLang="zh-TW" dirty="0"/>
+              <a:t>(Software Overhead)</a:t>
+            </a:r>
+            <a:r>
+              <a:rPr lang="zh-TW" altLang="en-US" dirty="0"/>
+              <a:t>。</a:t>
+            </a:r>
+          </a:p>
+        </p:txBody>
+      </p:sp>
+    </p:spTree>
+    <p:extLst>
+      <p:ext uri="{BB962C8B-B14F-4D97-AF65-F5344CB8AC3E}">
+        <p14:creationId xmlns:p14="http://schemas.microsoft.com/office/powerpoint/2010/main" val="3191696121"/>
+      </p:ext>
+    </p:extLst>
+  </p:cSld>
+  <p:clrMapOvr>
+    <a:masterClrMapping/>
+  </p:clrMapOvr>
+</p:sld>
+</file>
+
+<file path=ppt/slides/slide8.xml><?xml version="1.0" encoding="utf-8"?>
+<p:sld xmlns:a="http://schemas.openxmlformats.org/drawingml/2006/main" xmlns:r="http://schemas.openxmlformats.org/officeDocument/2006/relationships" xmlns:p="http://schemas.openxmlformats.org/presentationml/2006/main">
+  <p:cSld>
+    <p:spTree>
+      <p:nvGrpSpPr>
+        <p:cNvPr id="1" name=""/>
+        <p:cNvGrpSpPr/>
+        <p:nvPr/>
+      </p:nvGrpSpPr>
+      <p:grpSpPr>
+        <a:xfrm>
+          <a:off x="0" y="0"/>
+          <a:ext cx="0" cy="0"/>
+          <a:chOff x="0" y="0"/>
+          <a:chExt cx="0" cy="0"/>
+        </a:xfrm>
+      </p:grpSpPr>
+      <p:sp>
+        <p:nvSpPr>
+          <p:cNvPr id="2" name="標題 1">
+            <a:extLst>
+              <a:ext uri="{FF2B5EF4-FFF2-40B4-BE49-F238E27FC236}">
+                <a16:creationId xmlns:a16="http://schemas.microsoft.com/office/drawing/2014/main" id="{81C73F1F-9735-D4F7-FD68-75E8D5E53F78}"/>
+              </a:ext>
+            </a:extLst>
+          </p:cNvPr>
+          <p:cNvSpPr>
+            <a:spLocks noGrp="1"/>
+          </p:cNvSpPr>
+          <p:nvPr>
+            <p:ph type="title"/>
+          </p:nvPr>
+        </p:nvSpPr>
+        <p:spPr/>
+        <p:txBody>
+          <a:bodyPr/>
+          <a:lstStyle/>
+          <a:p>
+            <a:r>
+              <a:rPr lang="zh-TW" altLang="en-US" dirty="0"/>
+              <a:t>結論與未來展望 </a:t>
+            </a:r>
+          </a:p>
+        </p:txBody>
+      </p:sp>
+      <p:sp>
+        <p:nvSpPr>
+          <p:cNvPr id="3" name="內容版面配置區 2">
+            <a:extLst>
+              <a:ext uri="{FF2B5EF4-FFF2-40B4-BE49-F238E27FC236}">
+                <a16:creationId xmlns:a16="http://schemas.microsoft.com/office/drawing/2014/main" id="{3AAA66CF-91ED-9EA6-738E-721246DD7643}"/>
+              </a:ext>
+            </a:extLst>
+          </p:cNvPr>
+          <p:cNvSpPr>
+            <a:spLocks noGrp="1"/>
+          </p:cNvSpPr>
+          <p:nvPr>
+            <p:ph idx="1"/>
+          </p:nvPr>
+        </p:nvSpPr>
+        <p:spPr/>
+        <p:txBody>
+          <a:bodyPr/>
+          <a:lstStyle/>
+          <a:p>
+            <a:r>
+              <a:rPr lang="zh-TW" altLang="en-US" dirty="0"/>
+              <a:t>結論：成功完成從 </a:t>
+            </a:r>
+            <a:r>
+              <a:rPr lang="en-US" altLang="zh-TW" dirty="0"/>
+              <a:t>C++ </a:t>
+            </a:r>
+            <a:r>
+              <a:rPr lang="zh-TW" altLang="en-US" dirty="0"/>
+              <a:t>高階合成 </a:t>
+            </a:r>
+            <a:r>
+              <a:rPr lang="en-US" altLang="zh-TW" dirty="0"/>
+              <a:t>(HLS) </a:t>
+            </a:r>
+            <a:r>
+              <a:rPr lang="zh-TW" altLang="en-US" dirty="0"/>
+              <a:t>到 </a:t>
+            </a:r>
+            <a:r>
+              <a:rPr lang="en-US" altLang="zh-TW" dirty="0" err="1"/>
+              <a:t>Vivado</a:t>
+            </a:r>
+            <a:r>
+              <a:rPr lang="en-US" altLang="zh-TW" dirty="0"/>
+              <a:t> </a:t>
+            </a:r>
+            <a:r>
+              <a:rPr lang="zh-TW" altLang="en-US" dirty="0"/>
+              <a:t>系統整合，並於 </a:t>
+            </a:r>
+            <a:r>
+              <a:rPr lang="en-US" altLang="zh-TW" dirty="0"/>
+              <a:t>PYNQ </a:t>
+            </a:r>
+            <a:r>
+              <a:rPr lang="zh-TW" altLang="en-US" dirty="0"/>
+              <a:t>平台驗證軟硬體協同設計之可行性。</a:t>
+            </a:r>
+          </a:p>
+          <a:p>
+            <a:r>
+              <a:rPr lang="zh-TW" altLang="en-US" dirty="0"/>
+              <a:t>未來展望：若要進一步提升影片播放的流暢度，未來可考慮將影像解碼 </a:t>
+            </a:r>
+            <a:r>
+              <a:rPr lang="en-US" altLang="zh-TW" dirty="0"/>
+              <a:t>(Video Decoding) </a:t>
+            </a:r>
+            <a:r>
+              <a:rPr lang="zh-TW" altLang="en-US" dirty="0"/>
+              <a:t>或是 </a:t>
+            </a:r>
+            <a:r>
+              <a:rPr lang="en-US" altLang="zh-TW" dirty="0"/>
+              <a:t>HDMI </a:t>
+            </a:r>
+            <a:r>
+              <a:rPr lang="zh-TW" altLang="en-US" dirty="0"/>
+              <a:t>顯示介面 </a:t>
+            </a:r>
+            <a:r>
+              <a:rPr lang="en-US" altLang="zh-TW" dirty="0"/>
+              <a:t>(VDMA) </a:t>
+            </a:r>
+            <a:r>
+              <a:rPr lang="zh-TW" altLang="en-US" dirty="0"/>
+              <a:t>直接整合入 </a:t>
+            </a:r>
+            <a:r>
+              <a:rPr lang="en-US" altLang="zh-TW" dirty="0"/>
+              <a:t>FPGA </a:t>
+            </a:r>
+            <a:r>
+              <a:rPr lang="zh-TW" altLang="en-US" dirty="0"/>
+              <a:t>硬體層 </a:t>
+            </a:r>
+            <a:r>
+              <a:rPr lang="en-US" altLang="zh-TW" dirty="0"/>
+              <a:t>(PL </a:t>
+            </a:r>
+            <a:r>
+              <a:rPr lang="zh-TW" altLang="en-US" dirty="0"/>
+              <a:t>端</a:t>
+            </a:r>
+            <a:r>
+              <a:rPr lang="en-US" altLang="zh-TW" dirty="0"/>
+              <a:t>)</a:t>
+            </a:r>
+            <a:r>
+              <a:rPr lang="zh-TW" altLang="en-US" dirty="0"/>
+              <a:t>，以達成端到端 </a:t>
+            </a:r>
+            <a:r>
+              <a:rPr lang="en-US" altLang="zh-TW" dirty="0"/>
+              <a:t>(End-to-End) </a:t>
+            </a:r>
+            <a:r>
+              <a:rPr lang="zh-TW" altLang="en-US"/>
+              <a:t>的全硬體即時處理。</a:t>
+            </a:r>
+          </a:p>
+        </p:txBody>
+      </p:sp>
+    </p:spTree>
+    <p:extLst>
+      <p:ext uri="{BB962C8B-B14F-4D97-AF65-F5344CB8AC3E}">
+        <p14:creationId xmlns:p14="http://schemas.microsoft.com/office/powerpoint/2010/main" val="4106796880"/>
       </p:ext>
     </p:extLst>
   </p:cSld>

</xml_diff>